<commit_message>
refactor : add github links to reports
</commit_message>
<xml_diff>
--- a/reports/Customer_Shopping_Behavior_Business_Presentation.pptx
+++ b/reports/Customer_Shopping_Behavior_Business_Presentation.pptx
@@ -4,6 +4,9 @@
   <p:sldMasterIdLst>
     <p:sldMasterId id="2147483648" r:id="rId1"/>
   </p:sldMasterIdLst>
+  <p:notesMasterIdLst>
+    <p:notesMasterId r:id="rId11"/>
+  </p:notesMasterIdLst>
   <p:sldIdLst>
     <p:sldId id="256" r:id="rId2"/>
     <p:sldId id="257" r:id="rId3"/>
@@ -15,10 +18,7 @@
     <p:sldId id="263" r:id="rId9"/>
     <p:sldId id="264" r:id="rId10"/>
   </p:sldIdLst>
-  <p:notesMasterIdLst>
-    <p:notesMasterId r:id="rId11"/>
-  </p:notesMasterIdLst>
-  <p:sldSz cx="9144000" cy="5143500"/>
+  <p:sldSz cx="9144000" cy="5143500" type="screen16x9"/>
   <p:notesSz cx="5143500" cy="9144000"/>
   <p:defaultTextStyle>
     <a:lvl1pPr marL="0" algn="l" defTabSz="914400" rtl="0" eaLnBrk="1" latinLnBrk="0" hangingPunct="1">
@@ -112,7 +112,57 @@
       </a:defRPr>
     </a:lvl9pPr>
   </p:defaultTextStyle>
+  <p:extLst>
+    <p:ext uri="{EFAFB233-063F-42B5-8137-9DF3F51BA10A}">
+      <p15:sldGuideLst xmlns:p15="http://schemas.microsoft.com/office/powerpoint/2012/main"/>
+    </p:ext>
+  </p:extLst>
 </p:presentation>
+</file>
+
+<file path=ppt/revisionInfo.xml><?xml version="1.0" encoding="utf-8"?>
+<p1510:revInfo xmlns:a="http://schemas.openxmlformats.org/drawingml/2006/main" xmlns:r="http://schemas.openxmlformats.org/officeDocument/2006/relationships" xmlns:p1510="http://schemas.microsoft.com/office/powerpoint/2015/10/main">
+  <p1510:revLst>
+    <p1510:client id="{591E5757-5063-4AF9-84E1-10E441CA5995}" v="1" dt="2026-08-31T16:11:49.143"/>
+  </p1510:revLst>
+</p1510:revInfo>
+</file>
+
+<file path=ppt/changesInfos/changesInfo1.xml><?xml version="1.0" encoding="utf-8"?>
+<pc:chgInfo xmlns:a="http://schemas.openxmlformats.org/drawingml/2006/main" xmlns:r="http://schemas.openxmlformats.org/officeDocument/2006/relationships" xmlns:ac="http://schemas.microsoft.com/office/drawing/2013/main/command" xmlns:pc="http://schemas.microsoft.com/office/powerpoint/2013/main/command">
+  <pc:docChgLst>
+    <pc:chgData name="Jatoth Adithya Naik" userId="b27ada265e064ba5" providerId="LiveId" clId="{CE679E08-659B-4183-A436-400F9C527327}"/>
+    <pc:docChg chg="undo custSel modSld">
+      <pc:chgData name="Jatoth Adithya Naik" userId="b27ada265e064ba5" providerId="LiveId" clId="{CE679E08-659B-4183-A436-400F9C527327}" dt="2026-08-31T16:12:19.380" v="24" actId="207"/>
+      <pc:docMkLst>
+        <pc:docMk/>
+      </pc:docMkLst>
+      <pc:sldChg chg="addSp modSp mod">
+        <pc:chgData name="Jatoth Adithya Naik" userId="b27ada265e064ba5" providerId="LiveId" clId="{CE679E08-659B-4183-A436-400F9C527327}" dt="2026-08-31T16:12:19.380" v="24" actId="207"/>
+        <pc:sldMkLst>
+          <pc:docMk/>
+          <pc:sldMk cId="0" sldId="256"/>
+        </pc:sldMkLst>
+        <pc:spChg chg="mod">
+          <ac:chgData name="Jatoth Adithya Naik" userId="b27ada265e064ba5" providerId="LiveId" clId="{CE679E08-659B-4183-A436-400F9C527327}" dt="2026-08-31T16:11:15.954" v="5" actId="1076"/>
+          <ac:spMkLst>
+            <pc:docMk/>
+            <pc:sldMk cId="0" sldId="256"/>
+            <ac:spMk id="2" creationId="{00000000-0000-0000-0000-000000000000}"/>
+          </ac:spMkLst>
+        </pc:spChg>
+        <pc:spChg chg="add mod">
+          <ac:chgData name="Jatoth Adithya Naik" userId="b27ada265e064ba5" providerId="LiveId" clId="{CE679E08-659B-4183-A436-400F9C527327}" dt="2026-08-31T16:12:19.380" v="24" actId="207"/>
+          <ac:spMkLst>
+            <pc:docMk/>
+            <pc:sldMk cId="0" sldId="256"/>
+            <ac:spMk id="9" creationId="{A1527266-33F9-1643-5D57-6A33B01656FB}"/>
+          </ac:spMkLst>
+        </pc:spChg>
+      </pc:sldChg>
+    </pc:docChg>
+  </pc:docChgLst>
+</pc:chgInfo>
 </file>
 
 <file path=ppt/notesMasters/notesMaster1.xml><?xml version="1.0" encoding="utf-8"?>
@@ -137,234 +187,10 @@
           <a:chExt cx="0" cy="0"/>
         </a:xfrm>
       </p:grpSpPr>
-      <p:sp>
-        <p:nvSpPr>
-          <p:cNvPr id="2" name="Header Placeholder 1"/>
-          <p:cNvSpPr>
-            <a:spLocks noGrp="1"/>
-          </p:cNvSpPr>
-          <p:nvPr>
-            <p:ph type="hdr" sz="quarter"/>
-          </p:nvPr>
-        </p:nvSpPr>
-        <p:spPr>
-          <a:xfrm>
-            <a:off x="0" y="0"/>
-            <a:ext cx="2971800" cy="458788"/>
-          </a:xfrm>
-          <a:prstGeom prst="rect">
-            <a:avLst/>
-          </a:prstGeom>
-        </p:spPr>
-        <p:txBody>
-          <a:bodyPr vert="horz" lIns="91440" tIns="45720" rIns="91440" bIns="45720" rtlCol="0"/>
-          <a:lstStyle>
-            <a:lvl1pPr algn="l">
-              <a:defRPr sz="1200"/>
-            </a:lvl1pPr>
-          </a:lstStyle>
-          <a:p>
-            <a:endParaRPr lang="en-US"/>
-          </a:p>
-        </p:txBody>
-      </p:sp>
-      <p:sp>
-        <p:nvSpPr>
-          <p:cNvPr id="3" name="Date Placeholder 2"/>
-          <p:cNvSpPr>
-            <a:spLocks noGrp="1"/>
-          </p:cNvSpPr>
-          <p:nvPr>
-            <p:ph type="dt" idx="1"/>
-          </p:nvPr>
-        </p:nvSpPr>
-        <p:spPr>
-          <a:xfrm>
-            <a:off x="3884613" y="0"/>
-            <a:ext cx="2971800" cy="458788"/>
-          </a:xfrm>
-          <a:prstGeom prst="rect">
-            <a:avLst/>
-          </a:prstGeom>
-        </p:spPr>
-        <p:txBody>
-          <a:bodyPr vert="horz" lIns="91440" tIns="45720" rIns="91440" bIns="45720" rtlCol="0"/>
-          <a:lstStyle>
-            <a:lvl1pPr algn="r">
-              <a:defRPr sz="1200"/>
-            </a:lvl1pPr>
-          </a:lstStyle>
-          <a:p>
-            <a:fld id="{5282F153-3F37-0F45-9E97-73ACFA13230C}" type="datetimeFigureOut">
-              <a:rPr lang="en-US"/>
-              <a:t>7/23/19</a:t>
-            </a:fld>
-            <a:endParaRPr lang="en-US"/>
-          </a:p>
-        </p:txBody>
-      </p:sp>
-      <p:sp>
-        <p:nvSpPr>
-          <p:cNvPr id="4" name="Slide Image Placeholder 3"/>
-          <p:cNvSpPr>
-            <a:spLocks noGrp="1" noRot="1" noChangeAspect="1"/>
-          </p:cNvSpPr>
-          <p:nvPr>
-            <p:ph type="sldImg" idx="2"/>
-          </p:nvPr>
-        </p:nvSpPr>
-        <p:spPr>
-          <a:xfrm>
-            <a:off x="685800" y="1143000"/>
-            <a:ext cx="5486400" cy="3086100"/>
-          </a:xfrm>
-          <a:prstGeom prst="rect">
-            <a:avLst/>
-          </a:prstGeom>
-          <a:noFill/>
-          <a:ln w="12700">
-            <a:solidFill>
-              <a:prstClr val="black"/>
-            </a:solidFill>
-          </a:ln>
-        </p:spPr>
-        <p:txBody>
-          <a:bodyPr vert="horz" lIns="91440" tIns="45720" rIns="91440" bIns="45720" rtlCol="0" anchor="ctr"/>
-          <a:lstStyle/>
-          <a:p>
-            <a:endParaRPr lang="en-US"/>
-          </a:p>
-        </p:txBody>
-      </p:sp>
-      <p:sp>
-        <p:nvSpPr>
-          <p:cNvPr id="5" name="Notes Placeholder 4"/>
-          <p:cNvSpPr>
-            <a:spLocks noGrp="1"/>
-          </p:cNvSpPr>
-          <p:nvPr>
-            <p:ph type="body" sz="quarter" idx="3"/>
-          </p:nvPr>
-        </p:nvSpPr>
-        <p:spPr>
-          <a:xfrm>
-            <a:off x="685800" y="4400550"/>
-            <a:ext cx="5486400" cy="3600450"/>
-          </a:xfrm>
-          <a:prstGeom prst="rect">
-            <a:avLst/>
-          </a:prstGeom>
-        </p:spPr>
-        <p:txBody>
-          <a:bodyPr vert="horz" lIns="91440" tIns="45720" rIns="91440" bIns="45720" rtlCol="0"/>
-          <a:lstStyle/>
-          <a:p>
-            <a:pPr lvl="0"/>
-            <a:r>
-              <a:rPr lang="en-US"/>
-              <a:t>Click to edit Master text styles</a:t>
-            </a:r>
-          </a:p>
-          <a:p>
-            <a:pPr lvl="1"/>
-            <a:r>
-              <a:rPr lang="en-US"/>
-              <a:t>Second level</a:t>
-            </a:r>
-          </a:p>
-          <a:p>
-            <a:pPr lvl="2"/>
-            <a:r>
-              <a:rPr lang="en-US"/>
-              <a:t>Third level</a:t>
-            </a:r>
-          </a:p>
-          <a:p>
-            <a:pPr lvl="3"/>
-            <a:r>
-              <a:rPr lang="en-US"/>
-              <a:t>Fourth level</a:t>
-            </a:r>
-          </a:p>
-          <a:p>
-            <a:pPr lvl="4"/>
-            <a:r>
-              <a:rPr lang="en-US"/>
-              <a:t>Fifth level</a:t>
-            </a:r>
-          </a:p>
-        </p:txBody>
-      </p:sp>
-      <p:sp>
-        <p:nvSpPr>
-          <p:cNvPr id="6" name="Footer Placeholder 5"/>
-          <p:cNvSpPr>
-            <a:spLocks noGrp="1"/>
-          </p:cNvSpPr>
-          <p:nvPr>
-            <p:ph type="ftr" sz="quarter" idx="4"/>
-          </p:nvPr>
-        </p:nvSpPr>
-        <p:spPr>
-          <a:xfrm>
-            <a:off x="0" y="8685213"/>
-            <a:ext cx="2971800" cy="458787"/>
-          </a:xfrm>
-          <a:prstGeom prst="rect">
-            <a:avLst/>
-          </a:prstGeom>
-        </p:spPr>
-        <p:txBody>
-          <a:bodyPr vert="horz" lIns="91440" tIns="45720" rIns="91440" bIns="45720" rtlCol="0" anchor="b"/>
-          <a:lstStyle>
-            <a:lvl1pPr algn="l">
-              <a:defRPr sz="1200"/>
-            </a:lvl1pPr>
-          </a:lstStyle>
-          <a:p>
-            <a:endParaRPr lang="en-US"/>
-          </a:p>
-        </p:txBody>
-      </p:sp>
-      <p:sp>
-        <p:nvSpPr>
-          <p:cNvPr id="7" name="Slide Number Placeholder 6"/>
-          <p:cNvSpPr>
-            <a:spLocks noGrp="1"/>
-          </p:cNvSpPr>
-          <p:nvPr>
-            <p:ph type="sldNum" sz="quarter" idx="5"/>
-          </p:nvPr>
-        </p:nvSpPr>
-        <p:spPr>
-          <a:xfrm>
-            <a:off x="3884613" y="8685213"/>
-            <a:ext cx="2971800" cy="458787"/>
-          </a:xfrm>
-          <a:prstGeom prst="rect">
-            <a:avLst/>
-          </a:prstGeom>
-        </p:spPr>
-        <p:txBody>
-          <a:bodyPr vert="horz" lIns="91440" tIns="45720" rIns="91440" bIns="45720" rtlCol="0" anchor="b"/>
-          <a:lstStyle>
-            <a:lvl1pPr algn="r">
-              <a:defRPr sz="1200"/>
-            </a:lvl1pPr>
-          </a:lstStyle>
-          <a:p>
-            <a:fld id="{CE5E9CC1-C706-0F49-92D6-E571CC5EEA8F}" type="slidenum">
-              <a:rPr lang="en-US"/>
-              <a:t>‹#›</a:t>
-            </a:fld>
-            <a:endParaRPr lang="en-US"/>
-          </a:p>
-        </p:txBody>
-      </p:sp>
     </p:spTree>
     <p:extLst>
       <p:ext uri="{BB962C8B-B14F-4D97-AF65-F5344CB8AC3E}">
-        <p14:creationId xmlns:p14="http://schemas.microsoft.com/office/powerpoint/2010/main" val="1024086991"/>
+        <p14:creationId xmlns:p14="http://schemas.microsoft.com/office/powerpoint/2010/main" val="1282527563"/>
       </p:ext>
     </p:extLst>
   </p:cSld>
@@ -508,10 +334,6 @@
           <a:bodyPr/>
           <a:lstStyle/>
           <a:p>
-            <a:r>
-              <a:rPr lang="en-US" dirty="0"/>
-              <a:t/>
-            </a:r>
             <a:endParaRPr lang="en-US" dirty="0"/>
           </a:p>
         </p:txBody>
@@ -596,10 +418,6 @@
           <a:bodyPr/>
           <a:lstStyle/>
           <a:p>
-            <a:r>
-              <a:rPr lang="en-US" dirty="0"/>
-              <a:t/>
-            </a:r>
             <a:endParaRPr lang="en-US" dirty="0"/>
           </a:p>
         </p:txBody>
@@ -684,10 +502,6 @@
           <a:bodyPr/>
           <a:lstStyle/>
           <a:p>
-            <a:r>
-              <a:rPr lang="en-US" dirty="0"/>
-              <a:t/>
-            </a:r>
             <a:endParaRPr lang="en-US" dirty="0"/>
           </a:p>
         </p:txBody>
@@ -772,10 +586,6 @@
           <a:bodyPr/>
           <a:lstStyle/>
           <a:p>
-            <a:r>
-              <a:rPr lang="en-US" dirty="0"/>
-              <a:t/>
-            </a:r>
             <a:endParaRPr lang="en-US" dirty="0"/>
           </a:p>
         </p:txBody>
@@ -860,10 +670,6 @@
           <a:bodyPr/>
           <a:lstStyle/>
           <a:p>
-            <a:r>
-              <a:rPr lang="en-US" dirty="0"/>
-              <a:t/>
-            </a:r>
             <a:endParaRPr lang="en-US" dirty="0"/>
           </a:p>
         </p:txBody>
@@ -948,10 +754,6 @@
           <a:bodyPr/>
           <a:lstStyle/>
           <a:p>
-            <a:r>
-              <a:rPr lang="en-US" dirty="0"/>
-              <a:t/>
-            </a:r>
             <a:endParaRPr lang="en-US" dirty="0"/>
           </a:p>
         </p:txBody>
@@ -1036,10 +838,6 @@
           <a:bodyPr/>
           <a:lstStyle/>
           <a:p>
-            <a:r>
-              <a:rPr lang="en-US" dirty="0"/>
-              <a:t/>
-            </a:r>
             <a:endParaRPr lang="en-US" dirty="0"/>
           </a:p>
         </p:txBody>
@@ -1124,10 +922,6 @@
           <a:bodyPr/>
           <a:lstStyle/>
           <a:p>
-            <a:r>
-              <a:rPr lang="en-US" dirty="0"/>
-              <a:t/>
-            </a:r>
             <a:endParaRPr lang="en-US" dirty="0"/>
           </a:p>
         </p:txBody>
@@ -1212,10 +1006,6 @@
           <a:bodyPr/>
           <a:lstStyle/>
           <a:p>
-            <a:r>
-              <a:rPr lang="en-US" dirty="0"/>
-              <a:t/>
-            </a:r>
             <a:endParaRPr lang="en-US" dirty="0"/>
           </a:p>
         </p:txBody>
@@ -1289,6 +1079,11 @@
 <file path=ppt/slideMasters/slideMaster1.xml><?xml version="1.0" encoding="utf-8"?>
 <p:sldMaster xmlns:a="http://schemas.openxmlformats.org/drawingml/2006/main" xmlns:r="http://schemas.openxmlformats.org/officeDocument/2006/relationships" xmlns:p="http://schemas.openxmlformats.org/presentationml/2006/main">
   <p:cSld>
+    <p:bg>
+      <p:bgRef idx="1001">
+        <a:schemeClr val="bg1"/>
+      </p:bgRef>
+    </p:bg>
     <p:spTree>
       <p:nvGrpSpPr>
         <p:cNvPr id="1" name=""/>
@@ -1599,6 +1394,13 @@
           </a:solidFill>
           <a:ln/>
         </p:spPr>
+        <p:txBody>
+          <a:bodyPr/>
+          <a:lstStyle/>
+          <a:p>
+            <a:endParaRPr lang="en-IN" dirty="0"/>
+          </a:p>
+        </p:txBody>
       </p:sp>
       <p:sp>
         <p:nvSpPr>
@@ -1641,11 +1443,11 @@
           <a:bodyPr wrap="square" rtlCol="0" anchor="ctr"/>
           <a:lstStyle/>
           <a:p>
-            <a:pPr indent="0" marL="0">
-              <a:buNone/>
-            </a:pPr>
-            <a:r>
-              <a:rPr lang="en-US" sz="1400" b="1" spc="300" kern="0" dirty="0">
+            <a:pPr marL="0" indent="0">
+              <a:buNone/>
+            </a:pPr>
+            <a:r>
+              <a:rPr lang="en-US" sz="1400" b="1" kern="0" spc="300" dirty="0">
                 <a:solidFill>
                   <a:srgbClr val="AED6F1"/>
                 </a:solidFill>
@@ -1680,7 +1482,7 @@
           <a:bodyPr wrap="square" rtlCol="0" anchor="ctr"/>
           <a:lstStyle/>
           <a:p>
-            <a:pPr indent="0" marL="0">
+            <a:pPr marL="0" indent="0">
               <a:buNone/>
             </a:pPr>
             <a:r>
@@ -1697,7 +1499,7 @@
             <a:endParaRPr lang="en-US" sz="3600" dirty="0"/>
           </a:p>
           <a:p>
-            <a:pPr indent="0" marL="0">
+            <a:pPr marL="0" indent="0">
               <a:buNone/>
             </a:pPr>
             <a:r>
@@ -1736,7 +1538,7 @@
           <a:bodyPr wrap="square" rtlCol="0" anchor="ctr"/>
           <a:lstStyle/>
           <a:p>
-            <a:pPr indent="0" marL="0">
+            <a:pPr marL="0" indent="0">
               <a:buNone/>
             </a:pPr>
             <a:r>
@@ -1775,7 +1577,7 @@
           <a:bodyPr wrap="square" rtlCol="0" anchor="ctr"/>
           <a:lstStyle/>
           <a:p>
-            <a:pPr indent="0" marL="0">
+            <a:pPr marL="0" indent="0">
               <a:buNone/>
             </a:pPr>
             <a:r>
@@ -1790,6 +1592,66 @@
               <a:t>Retail Consumer Insights  |  3,900 Transactions  |  $233K Revenue</a:t>
             </a:r>
             <a:endParaRPr lang="en-US" sz="1300" dirty="0"/>
+          </a:p>
+        </p:txBody>
+      </p:sp>
+      <p:sp>
+        <p:nvSpPr>
+          <p:cNvPr id="9" name="Text 4">
+            <a:extLst>
+              <a:ext uri="{FF2B5EF4-FFF2-40B4-BE49-F238E27FC236}">
+                <a16:creationId xmlns:a16="http://schemas.microsoft.com/office/drawing/2014/main" id="{A1527266-33F9-1643-5D57-6A33B01656FB}"/>
+              </a:ext>
+            </a:extLst>
+          </p:cNvPr>
+          <p:cNvSpPr/>
+          <p:nvPr/>
+        </p:nvSpPr>
+        <p:spPr>
+          <a:xfrm>
+            <a:off x="548640" y="3543300"/>
+            <a:ext cx="8046720" cy="320040"/>
+          </a:xfrm>
+          <a:prstGeom prst="rect">
+            <a:avLst/>
+          </a:prstGeom>
+          <a:noFill/>
+          <a:ln/>
+        </p:spPr>
+        <p:txBody>
+          <a:bodyPr wrap="square" rtlCol="0" anchor="ctr"/>
+          <a:lstStyle/>
+          <a:p>
+            <a:pPr marL="0" indent="0">
+              <a:buNone/>
+            </a:pPr>
+            <a:r>
+              <a:rPr lang="en-US" sz="1500" dirty="0">
+                <a:solidFill>
+                  <a:srgbClr val="D4E6F1"/>
+                </a:solidFill>
+                <a:latin typeface="Calibri" pitchFamily="34" charset="0"/>
+                <a:ea typeface="Calibri" pitchFamily="34" charset="-122"/>
+                <a:cs typeface="Calibri" pitchFamily="34" charset="-120"/>
+              </a:rPr>
+              <a:t>GitHub : </a:t>
+            </a:r>
+            <a:r>
+              <a:rPr lang="en-US" sz="1500" dirty="0">
+                <a:latin typeface="Calibri" pitchFamily="34" charset="0"/>
+                <a:ea typeface="Calibri" pitchFamily="34" charset="-122"/>
+                <a:cs typeface="Calibri" pitchFamily="34" charset="-120"/>
+                <a:hlinkClick r:id="rId3">
+                  <a:extLst>
+                    <a:ext uri="{A12FA001-AC4F-418D-AE19-62706E023703}">
+                      <ahyp:hlinkClr xmlns:ahyp="http://schemas.microsoft.com/office/drawing/2018/hyperlinkcolor" val="tx"/>
+                    </a:ext>
+                  </a:extLst>
+                </a:hlinkClick>
+              </a:rPr>
+              <a:t>View Repo</a:t>
+            </a:r>
+            <a:endParaRPr lang="en-US" sz="1500" dirty="0"/>
           </a:p>
         </p:txBody>
       </p:sp>
@@ -1859,7 +1721,7 @@
           <a:bodyPr wrap="square" rtlCol="0" anchor="ctr"/>
           <a:lstStyle/>
           <a:p>
-            <a:pPr indent="0" marL="0">
+            <a:pPr marL="0" indent="0">
               <a:buNone/>
             </a:pPr>
             <a:r>
@@ -1940,7 +1802,7 @@
           <a:bodyPr wrap="square" rtlCol="0" anchor="ctr"/>
           <a:lstStyle/>
           <a:p>
-            <a:pPr indent="0" marL="0">
+            <a:pPr marL="0" indent="0">
               <a:buNone/>
             </a:pPr>
             <a:r>
@@ -1979,7 +1841,7 @@
           <a:bodyPr wrap="square" rtlCol="0" anchor="ctr"/>
           <a:lstStyle/>
           <a:p>
-            <a:pPr indent="0" marL="0">
+            <a:pPr marL="0" indent="0">
               <a:buNone/>
             </a:pPr>
             <a:r>
@@ -2040,7 +1902,7 @@
           <a:bodyPr wrap="square" rtlCol="0" anchor="ctr"/>
           <a:lstStyle/>
           <a:p>
-            <a:pPr algn="ctr" indent="0" marL="0">
+            <a:pPr marL="0" indent="0" algn="ctr">
               <a:buNone/>
             </a:pPr>
             <a:r>
@@ -2079,7 +1941,7 @@
           <a:bodyPr wrap="square" rtlCol="0" anchor="ctr"/>
           <a:lstStyle/>
           <a:p>
-            <a:pPr algn="ctr" indent="0" marL="0">
+            <a:pPr marL="0" indent="0" algn="ctr">
               <a:buNone/>
             </a:pPr>
             <a:r>
@@ -2118,7 +1980,7 @@
           <a:bodyPr wrap="square" rtlCol="0" anchor="ctr"/>
           <a:lstStyle/>
           <a:p>
-            <a:pPr algn="ctr" indent="0" marL="0">
+            <a:pPr marL="0" indent="0" algn="ctr">
               <a:buNone/>
             </a:pPr>
             <a:r>
@@ -2179,7 +2041,7 @@
           <a:bodyPr wrap="square" rtlCol="0" anchor="ctr"/>
           <a:lstStyle/>
           <a:p>
-            <a:pPr algn="ctr" indent="0" marL="0">
+            <a:pPr marL="0" indent="0" algn="ctr">
               <a:buNone/>
             </a:pPr>
             <a:r>
@@ -2218,7 +2080,7 @@
           <a:bodyPr wrap="square" rtlCol="0" anchor="ctr"/>
           <a:lstStyle/>
           <a:p>
-            <a:pPr algn="ctr" indent="0" marL="0">
+            <a:pPr marL="0" indent="0" algn="ctr">
               <a:buNone/>
             </a:pPr>
             <a:r>
@@ -2257,7 +2119,7 @@
           <a:bodyPr wrap="square" rtlCol="0" anchor="ctr"/>
           <a:lstStyle/>
           <a:p>
-            <a:pPr algn="ctr" indent="0" marL="0">
+            <a:pPr marL="0" indent="0" algn="ctr">
               <a:buNone/>
             </a:pPr>
             <a:r>
@@ -2318,7 +2180,7 @@
           <a:bodyPr wrap="square" rtlCol="0" anchor="ctr"/>
           <a:lstStyle/>
           <a:p>
-            <a:pPr algn="ctr" indent="0" marL="0">
+            <a:pPr marL="0" indent="0" algn="ctr">
               <a:buNone/>
             </a:pPr>
             <a:r>
@@ -2357,7 +2219,7 @@
           <a:bodyPr wrap="square" rtlCol="0" anchor="ctr"/>
           <a:lstStyle/>
           <a:p>
-            <a:pPr algn="ctr" indent="0" marL="0">
+            <a:pPr marL="0" indent="0" algn="ctr">
               <a:buNone/>
             </a:pPr>
             <a:r>
@@ -2396,7 +2258,7 @@
           <a:bodyPr wrap="square" rtlCol="0" anchor="ctr"/>
           <a:lstStyle/>
           <a:p>
-            <a:pPr algn="ctr" indent="0" marL="0">
+            <a:pPr marL="0" indent="0" algn="ctr">
               <a:buNone/>
             </a:pPr>
             <a:r>
@@ -2457,7 +2319,7 @@
           <a:bodyPr wrap="square" rtlCol="0" anchor="ctr"/>
           <a:lstStyle/>
           <a:p>
-            <a:pPr algn="ctr" indent="0" marL="0">
+            <a:pPr marL="0" indent="0" algn="ctr">
               <a:buNone/>
             </a:pPr>
             <a:r>
@@ -2496,7 +2358,7 @@
           <a:bodyPr wrap="square" rtlCol="0" anchor="ctr"/>
           <a:lstStyle/>
           <a:p>
-            <a:pPr algn="ctr" indent="0" marL="0">
+            <a:pPr marL="0" indent="0" algn="ctr">
               <a:buNone/>
             </a:pPr>
             <a:r>
@@ -2535,7 +2397,7 @@
           <a:bodyPr wrap="square" rtlCol="0" anchor="ctr"/>
           <a:lstStyle/>
           <a:p>
-            <a:pPr algn="ctr" indent="0" marL="0">
+            <a:pPr marL="0" indent="0" algn="ctr">
               <a:buNone/>
             </a:pPr>
             <a:r>
@@ -2596,7 +2458,7 @@
           <a:bodyPr wrap="square" rtlCol="0" anchor="ctr"/>
           <a:lstStyle/>
           <a:p>
-            <a:pPr algn="ctr" indent="0" marL="0">
+            <a:pPr marL="0" indent="0" algn="ctr">
               <a:buNone/>
             </a:pPr>
             <a:r>
@@ -2635,7 +2497,7 @@
           <a:bodyPr wrap="square" rtlCol="0" anchor="ctr"/>
           <a:lstStyle/>
           <a:p>
-            <a:pPr algn="ctr" indent="0" marL="0">
+            <a:pPr marL="0" indent="0" algn="ctr">
               <a:buNone/>
             </a:pPr>
             <a:r>
@@ -2674,7 +2536,7 @@
           <a:bodyPr wrap="square" rtlCol="0" anchor="ctr"/>
           <a:lstStyle/>
           <a:p>
-            <a:pPr algn="ctr" indent="0" marL="0">
+            <a:pPr marL="0" indent="0" algn="ctr">
               <a:buNone/>
             </a:pPr>
             <a:r>
@@ -2713,7 +2575,7 @@
           <a:bodyPr wrap="square" rtlCol="0" anchor="ctr"/>
           <a:lstStyle/>
           <a:p>
-            <a:pPr indent="0" marL="0">
+            <a:pPr marL="0" indent="0">
               <a:buNone/>
             </a:pPr>
             <a:r>
@@ -2797,7 +2659,7 @@
           <a:bodyPr wrap="square" rtlCol="0" anchor="ctr"/>
           <a:lstStyle/>
           <a:p>
-            <a:pPr indent="0" marL="0">
+            <a:pPr marL="0" indent="0">
               <a:buNone/>
             </a:pPr>
             <a:r>
@@ -2878,7 +2740,7 @@
           <a:bodyPr wrap="square" rtlCol="0" anchor="ctr"/>
           <a:lstStyle/>
           <a:p>
-            <a:pPr algn="ctr" indent="0" marL="0">
+            <a:pPr marL="0" indent="0" algn="ctr">
               <a:buNone/>
             </a:pPr>
             <a:r>
@@ -2917,7 +2779,7 @@
           <a:bodyPr wrap="square" rtlCol="0" anchor="ctr"/>
           <a:lstStyle/>
           <a:p>
-            <a:pPr algn="ctr" indent="0" marL="0">
+            <a:pPr marL="0" indent="0" algn="ctr">
               <a:buNone/>
             </a:pPr>
             <a:r>
@@ -2978,7 +2840,7 @@
           <a:bodyPr wrap="square" rtlCol="0" anchor="ctr"/>
           <a:lstStyle/>
           <a:p>
-            <a:pPr algn="ctr" indent="0" marL="0">
+            <a:pPr marL="0" indent="0" algn="ctr">
               <a:buNone/>
             </a:pPr>
             <a:r>
@@ -3017,7 +2879,7 @@
           <a:bodyPr wrap="square" rtlCol="0" anchor="ctr"/>
           <a:lstStyle/>
           <a:p>
-            <a:pPr algn="ctr" indent="0" marL="0">
+            <a:pPr marL="0" indent="0" algn="ctr">
               <a:buNone/>
             </a:pPr>
             <a:r>
@@ -3078,7 +2940,7 @@
           <a:bodyPr wrap="square" rtlCol="0" anchor="ctr"/>
           <a:lstStyle/>
           <a:p>
-            <a:pPr algn="ctr" indent="0" marL="0">
+            <a:pPr marL="0" indent="0" algn="ctr">
               <a:buNone/>
             </a:pPr>
             <a:r>
@@ -3117,7 +2979,7 @@
           <a:bodyPr wrap="square" rtlCol="0" anchor="ctr"/>
           <a:lstStyle/>
           <a:p>
-            <a:pPr algn="ctr" indent="0" marL="0">
+            <a:pPr marL="0" indent="0" algn="ctr">
               <a:buNone/>
             </a:pPr>
             <a:r>
@@ -3178,7 +3040,7 @@
           <a:bodyPr wrap="square" rtlCol="0" anchor="ctr"/>
           <a:lstStyle/>
           <a:p>
-            <a:pPr algn="ctr" indent="0" marL="0">
+            <a:pPr marL="0" indent="0" algn="ctr">
               <a:buNone/>
             </a:pPr>
             <a:r>
@@ -3217,7 +3079,7 @@
           <a:bodyPr wrap="square" rtlCol="0" anchor="ctr"/>
           <a:lstStyle/>
           <a:p>
-            <a:pPr algn="ctr" indent="0" marL="0">
+            <a:pPr marL="0" indent="0" algn="ctr">
               <a:buNone/>
             </a:pPr>
             <a:r>
@@ -3256,7 +3118,7 @@
           <a:bodyPr wrap="square" rtlCol="0" anchor="ctr"/>
           <a:lstStyle/>
           <a:p>
-            <a:pPr indent="0" marL="0">
+            <a:pPr marL="0" indent="0">
               <a:buNone/>
             </a:pPr>
             <a:r>
@@ -3295,7 +3157,7 @@
           <a:bodyPr wrap="square" rtlCol="0" anchor="ctr"/>
           <a:lstStyle/>
           <a:p>
-            <a:pPr indent="0" marL="0">
+            <a:pPr marL="0" indent="0">
               <a:buNone/>
             </a:pPr>
             <a:r>
@@ -3334,7 +3196,7 @@
           <a:bodyPr wrap="square" rtlCol="0" anchor="ctr"/>
           <a:lstStyle/>
           <a:p>
-            <a:pPr indent="0" marL="0">
+            <a:pPr marL="0" indent="0">
               <a:buNone/>
             </a:pPr>
             <a:r>
@@ -3373,7 +3235,7 @@
           <a:bodyPr wrap="square" rtlCol="0" anchor="ctr"/>
           <a:lstStyle/>
           <a:p>
-            <a:pPr indent="0" marL="0">
+            <a:pPr marL="0" indent="0">
               <a:buNone/>
             </a:pPr>
             <a:r>
@@ -3412,7 +3274,7 @@
           <a:bodyPr wrap="square" rtlCol="0" anchor="ctr"/>
           <a:lstStyle/>
           <a:p>
-            <a:pPr indent="0" marL="0">
+            <a:pPr marL="0" indent="0">
               <a:buNone/>
             </a:pPr>
             <a:r>
@@ -3451,7 +3313,7 @@
           <a:bodyPr wrap="square" rtlCol="0" anchor="ctr"/>
           <a:lstStyle/>
           <a:p>
-            <a:pPr indent="0" marL="0">
+            <a:pPr marL="0" indent="0">
               <a:buNone/>
             </a:pPr>
             <a:r>
@@ -3490,7 +3352,7 @@
           <a:bodyPr wrap="square" rtlCol="0" anchor="ctr"/>
           <a:lstStyle/>
           <a:p>
-            <a:pPr indent="0" marL="0">
+            <a:pPr marL="0" indent="0">
               <a:buNone/>
             </a:pPr>
             <a:r>
@@ -3529,7 +3391,7 @@
           <a:bodyPr wrap="square" rtlCol="0" anchor="ctr"/>
           <a:lstStyle/>
           <a:p>
-            <a:pPr indent="0" marL="0">
+            <a:pPr marL="0" indent="0">
               <a:buNone/>
             </a:pPr>
             <a:r>
@@ -3568,7 +3430,7 @@
           <a:bodyPr wrap="square" rtlCol="0" anchor="ctr"/>
           <a:lstStyle/>
           <a:p>
-            <a:pPr indent="0" marL="0">
+            <a:pPr marL="0" indent="0">
               <a:buNone/>
             </a:pPr>
             <a:r>
@@ -3607,7 +3469,7 @@
           <a:bodyPr wrap="square" rtlCol="0" anchor="ctr"/>
           <a:lstStyle/>
           <a:p>
-            <a:pPr indent="0" marL="0">
+            <a:pPr marL="0" indent="0">
               <a:buNone/>
             </a:pPr>
             <a:r>
@@ -3646,7 +3508,7 @@
           <a:bodyPr wrap="square" rtlCol="0" anchor="ctr"/>
           <a:lstStyle/>
           <a:p>
-            <a:pPr indent="0" marL="0">
+            <a:pPr marL="0" indent="0">
               <a:buNone/>
             </a:pPr>
             <a:r>
@@ -3685,7 +3547,7 @@
           <a:bodyPr wrap="square" rtlCol="0" anchor="ctr"/>
           <a:lstStyle/>
           <a:p>
-            <a:pPr indent="0" marL="0">
+            <a:pPr marL="0" indent="0">
               <a:buNone/>
             </a:pPr>
             <a:r>
@@ -3724,7 +3586,7 @@
           <a:bodyPr wrap="square" rtlCol="0" anchor="ctr"/>
           <a:lstStyle/>
           <a:p>
-            <a:pPr indent="0" marL="0">
+            <a:pPr marL="0" indent="0">
               <a:buNone/>
             </a:pPr>
             <a:r>
@@ -3808,7 +3670,7 @@
           <a:bodyPr wrap="square" rtlCol="0" anchor="ctr"/>
           <a:lstStyle/>
           <a:p>
-            <a:pPr indent="0" marL="0">
+            <a:pPr marL="0" indent="0">
               <a:buNone/>
             </a:pPr>
             <a:r>
@@ -3867,7 +3729,7 @@
           <a:bodyPr wrap="square" rtlCol="0" anchor="ctr"/>
           <a:lstStyle/>
           <a:p>
-            <a:pPr indent="0" marL="0">
+            <a:pPr marL="0" indent="0">
               <a:buNone/>
             </a:pPr>
             <a:r>
@@ -3928,7 +3790,7 @@
           <a:bodyPr wrap="square" rtlCol="0" anchor="ctr"/>
           <a:lstStyle/>
           <a:p>
-            <a:pPr indent="0" marL="0">
+            <a:pPr marL="0" indent="0">
               <a:buNone/>
             </a:pPr>
             <a:r>
@@ -3967,7 +3829,7 @@
           <a:bodyPr wrap="square" rtlCol="0" anchor="ctr"/>
           <a:lstStyle/>
           <a:p>
-            <a:pPr indent="0" marL="0">
+            <a:pPr marL="0" indent="0">
               <a:buNone/>
             </a:pPr>
             <a:r>
@@ -4006,7 +3868,7 @@
           <a:bodyPr wrap="square" rtlCol="0" anchor="ctr"/>
           <a:lstStyle/>
           <a:p>
-            <a:pPr indent="0" marL="0">
+            <a:pPr marL="0" indent="0">
               <a:buNone/>
             </a:pPr>
             <a:r>
@@ -4045,7 +3907,7 @@
           <a:bodyPr wrap="square" rtlCol="0" anchor="ctr"/>
           <a:lstStyle/>
           <a:p>
-            <a:pPr indent="0" marL="0">
+            <a:pPr marL="0" indent="0">
               <a:buNone/>
             </a:pPr>
             <a:r>
@@ -4084,7 +3946,7 @@
           <a:bodyPr wrap="square" rtlCol="0" anchor="ctr"/>
           <a:lstStyle/>
           <a:p>
-            <a:pPr indent="0" marL="0">
+            <a:pPr marL="0" indent="0">
               <a:buNone/>
             </a:pPr>
             <a:r>
@@ -4123,7 +3985,7 @@
           <a:bodyPr wrap="square" rtlCol="0" anchor="ctr"/>
           <a:lstStyle/>
           <a:p>
-            <a:pPr indent="0" marL="0">
+            <a:pPr marL="0" indent="0">
               <a:buNone/>
             </a:pPr>
             <a:r>
@@ -4162,7 +4024,7 @@
           <a:bodyPr wrap="square" rtlCol="0" anchor="ctr"/>
           <a:lstStyle/>
           <a:p>
-            <a:pPr indent="0" marL="0">
+            <a:pPr marL="0" indent="0">
               <a:buNone/>
             </a:pPr>
             <a:r>
@@ -4223,7 +4085,7 @@
           <a:bodyPr wrap="square" rtlCol="0" anchor="ctr"/>
           <a:lstStyle/>
           <a:p>
-            <a:pPr indent="0" marL="0">
+            <a:pPr marL="0" indent="0">
               <a:buNone/>
             </a:pPr>
             <a:r>
@@ -4262,7 +4124,7 @@
           <a:bodyPr wrap="square" rtlCol="0" anchor="ctr"/>
           <a:lstStyle/>
           <a:p>
-            <a:pPr indent="0" marL="0">
+            <a:pPr marL="0" indent="0">
               <a:buNone/>
             </a:pPr>
             <a:r>
@@ -4301,7 +4163,7 @@
           <a:bodyPr wrap="square" rtlCol="0" anchor="ctr"/>
           <a:lstStyle/>
           <a:p>
-            <a:pPr indent="0" marL="0">
+            <a:pPr marL="0" indent="0">
               <a:buNone/>
             </a:pPr>
             <a:r>
@@ -4340,7 +4202,7 @@
           <a:bodyPr wrap="square" rtlCol="0" anchor="ctr"/>
           <a:lstStyle/>
           <a:p>
-            <a:pPr indent="0" marL="0">
+            <a:pPr marL="0" indent="0">
               <a:buNone/>
             </a:pPr>
             <a:r>
@@ -4379,7 +4241,7 @@
           <a:bodyPr wrap="square" rtlCol="0" anchor="ctr"/>
           <a:lstStyle/>
           <a:p>
-            <a:pPr indent="0" marL="0">
+            <a:pPr marL="0" indent="0">
               <a:buNone/>
             </a:pPr>
             <a:r>
@@ -4418,7 +4280,7 @@
           <a:bodyPr wrap="square" rtlCol="0" anchor="ctr"/>
           <a:lstStyle/>
           <a:p>
-            <a:pPr indent="0" marL="0">
+            <a:pPr marL="0" indent="0">
               <a:buNone/>
             </a:pPr>
             <a:r>
@@ -4457,7 +4319,7 @@
           <a:bodyPr wrap="square" rtlCol="0" anchor="ctr"/>
           <a:lstStyle/>
           <a:p>
-            <a:pPr indent="0" marL="0">
+            <a:pPr marL="0" indent="0">
               <a:buNone/>
             </a:pPr>
             <a:r>
@@ -4496,7 +4358,7 @@
           <a:bodyPr wrap="square" rtlCol="0" anchor="ctr"/>
           <a:lstStyle/>
           <a:p>
-            <a:pPr indent="0" marL="0">
+            <a:pPr marL="0" indent="0">
               <a:buNone/>
             </a:pPr>
             <a:r>
@@ -4535,7 +4397,7 @@
           <a:bodyPr wrap="square" rtlCol="0" anchor="ctr"/>
           <a:lstStyle/>
           <a:p>
-            <a:pPr indent="0" marL="0">
+            <a:pPr marL="0" indent="0">
               <a:buNone/>
             </a:pPr>
             <a:r>
@@ -4574,7 +4436,7 @@
           <a:bodyPr wrap="square" rtlCol="0" anchor="ctr"/>
           <a:lstStyle/>
           <a:p>
-            <a:pPr indent="0" marL="0">
+            <a:pPr marL="0" indent="0">
               <a:buNone/>
             </a:pPr>
             <a:r>
@@ -4613,7 +4475,7 @@
           <a:bodyPr wrap="square" rtlCol="0" anchor="ctr"/>
           <a:lstStyle/>
           <a:p>
-            <a:pPr indent="0" marL="0">
+            <a:pPr marL="0" indent="0">
               <a:buNone/>
             </a:pPr>
             <a:r>
@@ -4652,7 +4514,7 @@
           <a:bodyPr wrap="square" rtlCol="0" anchor="ctr"/>
           <a:lstStyle/>
           <a:p>
-            <a:pPr indent="0" marL="0">
+            <a:pPr marL="0" indent="0">
               <a:buNone/>
             </a:pPr>
             <a:r>
@@ -4691,7 +4553,7 @@
           <a:bodyPr wrap="square" rtlCol="0" anchor="ctr"/>
           <a:lstStyle/>
           <a:p>
-            <a:pPr indent="0" marL="0">
+            <a:pPr marL="0" indent="0">
               <a:buNone/>
             </a:pPr>
             <a:r>
@@ -4772,7 +4634,7 @@
           <a:bodyPr wrap="square" rtlCol="0" anchor="ctr"/>
           <a:lstStyle/>
           <a:p>
-            <a:pPr indent="0" marL="0">
+            <a:pPr marL="0" indent="0">
               <a:buNone/>
             </a:pPr>
             <a:r>
@@ -4811,7 +4673,7 @@
           <a:bodyPr wrap="square" rtlCol="0" anchor="ctr"/>
           <a:lstStyle/>
           <a:p>
-            <a:pPr indent="0" marL="0">
+            <a:pPr marL="0" indent="0">
               <a:buNone/>
             </a:pPr>
             <a:r>
@@ -4850,7 +4712,7 @@
           <a:bodyPr wrap="square" rtlCol="0" anchor="ctr"/>
           <a:lstStyle/>
           <a:p>
-            <a:pPr indent="0" marL="0">
+            <a:pPr marL="0" indent="0">
               <a:buNone/>
             </a:pPr>
             <a:r>
@@ -4931,7 +4793,7 @@
           <a:bodyPr wrap="square" rtlCol="0" anchor="ctr"/>
           <a:lstStyle/>
           <a:p>
-            <a:pPr indent="0" marL="0">
+            <a:pPr marL="0" indent="0">
               <a:buNone/>
             </a:pPr>
             <a:r>
@@ -4970,7 +4832,7 @@
           <a:bodyPr wrap="square" rtlCol="0" anchor="ctr"/>
           <a:lstStyle/>
           <a:p>
-            <a:pPr indent="0" marL="0">
+            <a:pPr marL="0" indent="0">
               <a:buNone/>
             </a:pPr>
             <a:r>
@@ -5009,7 +4871,7 @@
           <a:bodyPr wrap="square" rtlCol="0" anchor="ctr"/>
           <a:lstStyle/>
           <a:p>
-            <a:pPr indent="0" marL="0">
+            <a:pPr marL="0" indent="0">
               <a:buNone/>
             </a:pPr>
             <a:r>
@@ -5090,7 +4952,7 @@
           <a:bodyPr wrap="square" rtlCol="0" anchor="ctr"/>
           <a:lstStyle/>
           <a:p>
-            <a:pPr indent="0" marL="0">
+            <a:pPr marL="0" indent="0">
               <a:buNone/>
             </a:pPr>
             <a:r>
@@ -5129,7 +4991,7 @@
           <a:bodyPr wrap="square" rtlCol="0" anchor="ctr"/>
           <a:lstStyle/>
           <a:p>
-            <a:pPr indent="0" marL="0">
+            <a:pPr marL="0" indent="0">
               <a:buNone/>
             </a:pPr>
             <a:r>
@@ -5168,7 +5030,7 @@
           <a:bodyPr wrap="square" rtlCol="0" anchor="ctr"/>
           <a:lstStyle/>
           <a:p>
-            <a:pPr indent="0" marL="0">
+            <a:pPr marL="0" indent="0">
               <a:buNone/>
             </a:pPr>
             <a:r>
@@ -5207,7 +5069,7 @@
           <a:bodyPr wrap="square" rtlCol="0" anchor="ctr"/>
           <a:lstStyle/>
           <a:p>
-            <a:pPr indent="0" marL="0">
+            <a:pPr marL="0" indent="0">
               <a:buNone/>
             </a:pPr>
             <a:r>
@@ -5291,7 +5153,7 @@
           <a:bodyPr wrap="square" rtlCol="0" anchor="ctr"/>
           <a:lstStyle/>
           <a:p>
-            <a:pPr indent="0" marL="0">
+            <a:pPr marL="0" indent="0">
               <a:buNone/>
             </a:pPr>
             <a:r>
@@ -5350,7 +5212,7 @@
           <a:bodyPr wrap="square" rtlCol="0" anchor="ctr"/>
           <a:lstStyle/>
           <a:p>
-            <a:pPr indent="0" marL="0">
+            <a:pPr marL="0" indent="0">
               <a:buNone/>
             </a:pPr>
             <a:r>
@@ -5411,7 +5273,7 @@
           <a:bodyPr wrap="square" rtlCol="0" anchor="ctr"/>
           <a:lstStyle/>
           <a:p>
-            <a:pPr indent="0" marL="0">
+            <a:pPr marL="0" indent="0">
               <a:buNone/>
             </a:pPr>
             <a:r>
@@ -5450,7 +5312,7 @@
           <a:bodyPr wrap="square" rtlCol="0" anchor="ctr"/>
           <a:lstStyle/>
           <a:p>
-            <a:pPr indent="0" marL="0">
+            <a:pPr marL="0" indent="0">
               <a:buNone/>
             </a:pPr>
             <a:r>
@@ -5489,7 +5351,7 @@
           <a:bodyPr wrap="square" rtlCol="0" anchor="ctr"/>
           <a:lstStyle/>
           <a:p>
-            <a:pPr indent="0" marL="0">
+            <a:pPr marL="0" indent="0">
               <a:buNone/>
             </a:pPr>
             <a:r>
@@ -5528,7 +5390,7 @@
           <a:bodyPr wrap="square" rtlCol="0" anchor="ctr"/>
           <a:lstStyle/>
           <a:p>
-            <a:pPr indent="0" marL="0">
+            <a:pPr marL="0" indent="0">
               <a:buNone/>
             </a:pPr>
             <a:r>
@@ -5589,7 +5451,7 @@
           <a:bodyPr wrap="square" rtlCol="0" anchor="ctr"/>
           <a:lstStyle/>
           <a:p>
-            <a:pPr indent="0" marL="0">
+            <a:pPr marL="0" indent="0">
               <a:buNone/>
             </a:pPr>
             <a:r>
@@ -5628,7 +5490,7 @@
           <a:bodyPr wrap="square" rtlCol="0" anchor="ctr"/>
           <a:lstStyle/>
           <a:p>
-            <a:pPr indent="0" marL="0">
+            <a:pPr marL="0" indent="0">
               <a:buNone/>
             </a:pPr>
             <a:r>
@@ -5667,7 +5529,7 @@
           <a:bodyPr wrap="square" rtlCol="0" anchor="ctr"/>
           <a:lstStyle/>
           <a:p>
-            <a:pPr indent="0" marL="0">
+            <a:pPr marL="0" indent="0">
               <a:buNone/>
             </a:pPr>
             <a:r>
@@ -5706,7 +5568,7 @@
           <a:bodyPr wrap="square" rtlCol="0" anchor="ctr"/>
           <a:lstStyle/>
           <a:p>
-            <a:pPr indent="0" marL="0">
+            <a:pPr marL="0" indent="0">
               <a:buNone/>
             </a:pPr>
             <a:r>
@@ -5767,7 +5629,7 @@
           <a:bodyPr wrap="square" rtlCol="0" anchor="ctr"/>
           <a:lstStyle/>
           <a:p>
-            <a:pPr indent="0" marL="0">
+            <a:pPr marL="0" indent="0">
               <a:buNone/>
             </a:pPr>
             <a:r>
@@ -5806,7 +5668,7 @@
           <a:bodyPr wrap="square" rtlCol="0" anchor="ctr"/>
           <a:lstStyle/>
           <a:p>
-            <a:pPr indent="0" marL="0">
+            <a:pPr marL="0" indent="0">
               <a:buNone/>
             </a:pPr>
             <a:r>
@@ -5867,7 +5729,7 @@
           <a:bodyPr wrap="square" rtlCol="0" anchor="ctr"/>
           <a:lstStyle/>
           <a:p>
-            <a:pPr algn="ctr" indent="0" marL="0">
+            <a:pPr marL="0" indent="0" algn="ctr">
               <a:buNone/>
             </a:pPr>
             <a:r>
@@ -5906,7 +5768,7 @@
           <a:bodyPr wrap="square" rtlCol="0" anchor="ctr"/>
           <a:lstStyle/>
           <a:p>
-            <a:pPr algn="ctr" indent="0" marL="0">
+            <a:pPr marL="0" indent="0" algn="ctr">
               <a:buNone/>
             </a:pPr>
             <a:r>
@@ -5967,7 +5829,7 @@
           <a:bodyPr wrap="square" rtlCol="0" anchor="ctr"/>
           <a:lstStyle/>
           <a:p>
-            <a:pPr algn="ctr" indent="0" marL="0">
+            <a:pPr marL="0" indent="0" algn="ctr">
               <a:buNone/>
             </a:pPr>
             <a:r>
@@ -6006,7 +5868,7 @@
           <a:bodyPr wrap="square" rtlCol="0" anchor="ctr"/>
           <a:lstStyle/>
           <a:p>
-            <a:pPr algn="ctr" indent="0" marL="0">
+            <a:pPr marL="0" indent="0" algn="ctr">
               <a:buNone/>
             </a:pPr>
             <a:r>
@@ -6067,7 +5929,7 @@
           <a:bodyPr wrap="square" rtlCol="0" anchor="ctr"/>
           <a:lstStyle/>
           <a:p>
-            <a:pPr algn="ctr" indent="0" marL="0">
+            <a:pPr marL="0" indent="0" algn="ctr">
               <a:buNone/>
             </a:pPr>
             <a:r>
@@ -6106,7 +5968,7 @@
           <a:bodyPr wrap="square" rtlCol="0" anchor="ctr"/>
           <a:lstStyle/>
           <a:p>
-            <a:pPr algn="ctr" indent="0" marL="0">
+            <a:pPr marL="0" indent="0" algn="ctr">
               <a:buNone/>
             </a:pPr>
             <a:r>
@@ -6167,7 +6029,7 @@
           <a:bodyPr wrap="square" rtlCol="0" anchor="ctr"/>
           <a:lstStyle/>
           <a:p>
-            <a:pPr algn="ctr" indent="0" marL="0">
+            <a:pPr marL="0" indent="0" algn="ctr">
               <a:buNone/>
             </a:pPr>
             <a:r>
@@ -6206,7 +6068,7 @@
           <a:bodyPr wrap="square" rtlCol="0" anchor="ctr"/>
           <a:lstStyle/>
           <a:p>
-            <a:pPr algn="ctr" indent="0" marL="0">
+            <a:pPr marL="0" indent="0" algn="ctr">
               <a:buNone/>
             </a:pPr>
             <a:r>
@@ -6267,7 +6129,7 @@
           <a:bodyPr wrap="square" rtlCol="0" anchor="ctr"/>
           <a:lstStyle/>
           <a:p>
-            <a:pPr algn="ctr" indent="0" marL="0">
+            <a:pPr marL="0" indent="0" algn="ctr">
               <a:buNone/>
             </a:pPr>
             <a:r>
@@ -6306,7 +6168,7 @@
           <a:bodyPr wrap="square" rtlCol="0" anchor="ctr"/>
           <a:lstStyle/>
           <a:p>
-            <a:pPr algn="ctr" indent="0" marL="0">
+            <a:pPr marL="0" indent="0" algn="ctr">
               <a:buNone/>
             </a:pPr>
             <a:r>
@@ -6345,7 +6207,7 @@
           <a:bodyPr wrap="square" rtlCol="0" anchor="ctr"/>
           <a:lstStyle/>
           <a:p>
-            <a:pPr indent="0" marL="0">
+            <a:pPr marL="0" indent="0">
               <a:buNone/>
             </a:pPr>
             <a:r>
@@ -6429,7 +6291,7 @@
           <a:bodyPr wrap="square" rtlCol="0" anchor="ctr"/>
           <a:lstStyle/>
           <a:p>
-            <a:pPr indent="0" marL="0">
+            <a:pPr marL="0" indent="0">
               <a:buNone/>
             </a:pPr>
             <a:r>
@@ -6488,7 +6350,7 @@
           <a:bodyPr wrap="square" rtlCol="0" anchor="ctr"/>
           <a:lstStyle/>
           <a:p>
-            <a:pPr indent="0" marL="0">
+            <a:pPr marL="0" indent="0">
               <a:buNone/>
             </a:pPr>
             <a:r>
@@ -6549,7 +6411,7 @@
           <a:bodyPr wrap="square" rtlCol="0" anchor="ctr"/>
           <a:lstStyle/>
           <a:p>
-            <a:pPr indent="0" marL="0">
+            <a:pPr marL="0" indent="0">
               <a:buNone/>
             </a:pPr>
             <a:r>
@@ -6588,7 +6450,7 @@
           <a:bodyPr wrap="square" rtlCol="0" anchor="ctr"/>
           <a:lstStyle/>
           <a:p>
-            <a:pPr indent="0" marL="0">
+            <a:pPr marL="0" indent="0">
               <a:buNone/>
             </a:pPr>
             <a:r>
@@ -6627,7 +6489,7 @@
           <a:bodyPr wrap="square" rtlCol="0" anchor="ctr"/>
           <a:lstStyle/>
           <a:p>
-            <a:pPr indent="0" marL="0">
+            <a:pPr marL="0" indent="0">
               <a:buNone/>
             </a:pPr>
             <a:r>
@@ -6688,7 +6550,7 @@
           <a:bodyPr wrap="square" rtlCol="0" anchor="ctr"/>
           <a:lstStyle/>
           <a:p>
-            <a:pPr indent="0" marL="0">
+            <a:pPr marL="0" indent="0">
               <a:buNone/>
             </a:pPr>
             <a:r>
@@ -6727,7 +6589,7 @@
           <a:bodyPr wrap="square" rtlCol="0" anchor="ctr"/>
           <a:lstStyle/>
           <a:p>
-            <a:pPr indent="0" marL="0">
+            <a:pPr marL="0" indent="0">
               <a:buNone/>
             </a:pPr>
             <a:r>
@@ -6766,7 +6628,7 @@
           <a:bodyPr wrap="square" rtlCol="0" anchor="ctr"/>
           <a:lstStyle/>
           <a:p>
-            <a:pPr indent="0" marL="0">
+            <a:pPr marL="0" indent="0">
               <a:buNone/>
             </a:pPr>
             <a:r>
@@ -6827,7 +6689,7 @@
           <a:bodyPr wrap="square" rtlCol="0" anchor="ctr"/>
           <a:lstStyle/>
           <a:p>
-            <a:pPr indent="0" marL="0">
+            <a:pPr marL="0" indent="0">
               <a:buNone/>
             </a:pPr>
             <a:r>
@@ -6866,7 +6728,7 @@
           <a:bodyPr wrap="square" rtlCol="0" anchor="ctr"/>
           <a:lstStyle/>
           <a:p>
-            <a:pPr indent="0" marL="0">
+            <a:pPr marL="0" indent="0">
               <a:buNone/>
             </a:pPr>
             <a:r>
@@ -6905,7 +6767,7 @@
           <a:bodyPr wrap="square" rtlCol="0" anchor="ctr"/>
           <a:lstStyle/>
           <a:p>
-            <a:pPr indent="0" marL="0">
+            <a:pPr marL="0" indent="0">
               <a:buNone/>
             </a:pPr>
             <a:r>
@@ -6966,7 +6828,7 @@
           <a:bodyPr wrap="square" rtlCol="0" anchor="ctr"/>
           <a:lstStyle/>
           <a:p>
-            <a:pPr indent="0" marL="0">
+            <a:pPr marL="0" indent="0">
               <a:buNone/>
             </a:pPr>
             <a:r>
@@ -7005,7 +6867,7 @@
           <a:bodyPr wrap="square" rtlCol="0" anchor="ctr"/>
           <a:lstStyle/>
           <a:p>
-            <a:pPr indent="0" marL="0">
+            <a:pPr marL="0" indent="0">
               <a:buNone/>
             </a:pPr>
             <a:r>
@@ -7044,7 +6906,7 @@
           <a:bodyPr wrap="square" rtlCol="0" anchor="ctr"/>
           <a:lstStyle/>
           <a:p>
-            <a:pPr indent="0" marL="0">
+            <a:pPr marL="0" indent="0">
               <a:buNone/>
             </a:pPr>
             <a:r>
@@ -7105,7 +6967,7 @@
           <a:bodyPr wrap="square" rtlCol="0" anchor="ctr"/>
           <a:lstStyle/>
           <a:p>
-            <a:pPr indent="0" marL="0">
+            <a:pPr marL="0" indent="0">
               <a:buNone/>
             </a:pPr>
             <a:r>
@@ -7144,7 +7006,7 @@
           <a:bodyPr wrap="square" rtlCol="0" anchor="ctr"/>
           <a:lstStyle/>
           <a:p>
-            <a:pPr indent="0" marL="0">
+            <a:pPr marL="0" indent="0">
               <a:buNone/>
             </a:pPr>
             <a:r>
@@ -7183,7 +7045,7 @@
           <a:bodyPr wrap="square" rtlCol="0" anchor="ctr"/>
           <a:lstStyle/>
           <a:p>
-            <a:pPr indent="0" marL="0">
+            <a:pPr marL="0" indent="0">
               <a:buNone/>
             </a:pPr>
             <a:r>
@@ -7222,7 +7084,7 @@
           <a:bodyPr wrap="square" rtlCol="0" anchor="ctr"/>
           <a:lstStyle/>
           <a:p>
-            <a:pPr indent="0" marL="0">
+            <a:pPr marL="0" indent="0">
               <a:buNone/>
             </a:pPr>
             <a:r>
@@ -7283,7 +7145,7 @@
           <a:bodyPr wrap="square" rtlCol="0" anchor="ctr"/>
           <a:lstStyle/>
           <a:p>
-            <a:pPr indent="0" marL="0">
+            <a:pPr marL="0" indent="0">
               <a:buNone/>
             </a:pPr>
             <a:r>
@@ -7322,7 +7184,7 @@
           <a:bodyPr wrap="square" rtlCol="0" anchor="ctr"/>
           <a:lstStyle/>
           <a:p>
-            <a:pPr indent="0" marL="0">
+            <a:pPr marL="0" indent="0">
               <a:buNone/>
             </a:pPr>
             <a:r>
@@ -7383,7 +7245,7 @@
           <a:bodyPr wrap="square" rtlCol="0" anchor="ctr"/>
           <a:lstStyle/>
           <a:p>
-            <a:pPr indent="0" marL="0">
+            <a:pPr marL="0" indent="0">
               <a:buNone/>
             </a:pPr>
             <a:r>
@@ -7422,7 +7284,7 @@
           <a:bodyPr wrap="square" rtlCol="0" anchor="ctr"/>
           <a:lstStyle/>
           <a:p>
-            <a:pPr indent="0" marL="0">
+            <a:pPr marL="0" indent="0">
               <a:buNone/>
             </a:pPr>
             <a:r>
@@ -7483,7 +7345,7 @@
           <a:bodyPr wrap="square" rtlCol="0" anchor="ctr"/>
           <a:lstStyle/>
           <a:p>
-            <a:pPr indent="0" marL="0">
+            <a:pPr marL="0" indent="0">
               <a:buNone/>
             </a:pPr>
             <a:r>
@@ -7522,7 +7384,7 @@
           <a:bodyPr wrap="square" rtlCol="0" anchor="ctr"/>
           <a:lstStyle/>
           <a:p>
-            <a:pPr indent="0" marL="0">
+            <a:pPr marL="0" indent="0">
               <a:buNone/>
             </a:pPr>
             <a:r>
@@ -7583,7 +7445,7 @@
           <a:bodyPr wrap="square" rtlCol="0" anchor="ctr"/>
           <a:lstStyle/>
           <a:p>
-            <a:pPr indent="0" marL="0">
+            <a:pPr marL="0" indent="0">
               <a:buNone/>
             </a:pPr>
             <a:r>
@@ -7622,7 +7484,7 @@
           <a:bodyPr wrap="square" rtlCol="0" anchor="ctr"/>
           <a:lstStyle/>
           <a:p>
-            <a:pPr indent="0" marL="0">
+            <a:pPr marL="0" indent="0">
               <a:buNone/>
             </a:pPr>
             <a:r>
@@ -7683,7 +7545,7 @@
           <a:bodyPr wrap="square" rtlCol="0" anchor="ctr"/>
           <a:lstStyle/>
           <a:p>
-            <a:pPr indent="0" marL="0">
+            <a:pPr marL="0" indent="0">
               <a:buNone/>
             </a:pPr>
             <a:r>
@@ -7722,7 +7584,7 @@
           <a:bodyPr wrap="square" rtlCol="0" anchor="ctr"/>
           <a:lstStyle/>
           <a:p>
-            <a:pPr indent="0" marL="0">
+            <a:pPr marL="0" indent="0">
               <a:buNone/>
             </a:pPr>
             <a:r>
@@ -7806,7 +7668,7 @@
           <a:bodyPr wrap="square" rtlCol="0" anchor="ctr"/>
           <a:lstStyle/>
           <a:p>
-            <a:pPr indent="0" marL="0">
+            <a:pPr marL="0" indent="0">
               <a:buNone/>
             </a:pPr>
             <a:r>
@@ -7865,7 +7727,7 @@
           <a:bodyPr wrap="square" rtlCol="0" anchor="ctr"/>
           <a:lstStyle/>
           <a:p>
-            <a:pPr indent="0" marL="0">
+            <a:pPr marL="0" indent="0">
               <a:buNone/>
             </a:pPr>
             <a:r>
@@ -7926,7 +7788,7 @@
           <a:bodyPr wrap="square" rtlCol="0" anchor="ctr"/>
           <a:lstStyle/>
           <a:p>
-            <a:pPr indent="0" marL="0">
+            <a:pPr marL="0" indent="0">
               <a:buNone/>
             </a:pPr>
             <a:r>
@@ -7965,7 +7827,7 @@
           <a:bodyPr wrap="square" rtlCol="0" anchor="ctr"/>
           <a:lstStyle/>
           <a:p>
-            <a:pPr indent="0" marL="0">
+            <a:pPr marL="0" indent="0">
               <a:buNone/>
             </a:pPr>
             <a:r>
@@ -8004,7 +7866,7 @@
           <a:bodyPr wrap="square" rtlCol="0" anchor="ctr"/>
           <a:lstStyle/>
           <a:p>
-            <a:pPr indent="0" marL="0">
+            <a:pPr marL="0" indent="0">
               <a:buNone/>
             </a:pPr>
             <a:r>
@@ -8065,7 +7927,7 @@
           <a:bodyPr wrap="square" rtlCol="0" anchor="ctr"/>
           <a:lstStyle/>
           <a:p>
-            <a:pPr indent="0" marL="0">
+            <a:pPr marL="0" indent="0">
               <a:buNone/>
             </a:pPr>
             <a:r>
@@ -8104,7 +7966,7 @@
           <a:bodyPr wrap="square" rtlCol="0" anchor="ctr"/>
           <a:lstStyle/>
           <a:p>
-            <a:pPr indent="0" marL="0">
+            <a:pPr marL="0" indent="0">
               <a:buNone/>
             </a:pPr>
             <a:r>
@@ -8143,7 +8005,7 @@
           <a:bodyPr wrap="square" rtlCol="0" anchor="ctr"/>
           <a:lstStyle/>
           <a:p>
-            <a:pPr indent="0" marL="0">
+            <a:pPr marL="0" indent="0">
               <a:buNone/>
             </a:pPr>
             <a:r>
@@ -8204,7 +8066,7 @@
           <a:bodyPr wrap="square" rtlCol="0" anchor="ctr"/>
           <a:lstStyle/>
           <a:p>
-            <a:pPr indent="0" marL="0">
+            <a:pPr marL="0" indent="0">
               <a:buNone/>
             </a:pPr>
             <a:r>
@@ -8243,7 +8105,7 @@
           <a:bodyPr wrap="square" rtlCol="0" anchor="ctr"/>
           <a:lstStyle/>
           <a:p>
-            <a:pPr indent="0" marL="0">
+            <a:pPr marL="0" indent="0">
               <a:buNone/>
             </a:pPr>
             <a:r>
@@ -8304,7 +8166,7 @@
           <a:bodyPr wrap="square" rtlCol="0" anchor="ctr"/>
           <a:lstStyle/>
           <a:p>
-            <a:pPr indent="0" marL="0">
+            <a:pPr marL="0" indent="0">
               <a:buNone/>
             </a:pPr>
             <a:r>
@@ -8343,7 +8205,7 @@
           <a:bodyPr wrap="square" rtlCol="0" anchor="ctr"/>
           <a:lstStyle/>
           <a:p>
-            <a:pPr indent="0" marL="0">
+            <a:pPr marL="0" indent="0">
               <a:buNone/>
             </a:pPr>
             <a:r>
@@ -8382,7 +8244,7 @@
           <a:bodyPr wrap="square" rtlCol="0" anchor="ctr"/>
           <a:lstStyle/>
           <a:p>
-            <a:pPr indent="0" marL="0">
+            <a:pPr marL="0" indent="0">
               <a:buNone/>
             </a:pPr>
             <a:r>
@@ -8466,7 +8328,7 @@
           <a:bodyPr wrap="square" rtlCol="0" anchor="ctr"/>
           <a:lstStyle/>
           <a:p>
-            <a:pPr indent="0" marL="0">
+            <a:pPr marL="0" indent="0">
               <a:buNone/>
             </a:pPr>
             <a:r>
@@ -8547,7 +8409,7 @@
           <a:bodyPr wrap="square" rtlCol="0" anchor="ctr"/>
           <a:lstStyle/>
           <a:p>
-            <a:pPr indent="0" marL="0">
+            <a:pPr marL="0" indent="0">
               <a:buNone/>
             </a:pPr>
             <a:r>
@@ -8586,7 +8448,7 @@
           <a:bodyPr wrap="square" rtlCol="0" anchor="ctr"/>
           <a:lstStyle/>
           <a:p>
-            <a:pPr indent="0" marL="0">
+            <a:pPr marL="0" indent="0">
               <a:buNone/>
             </a:pPr>
             <a:r>
@@ -8625,7 +8487,7 @@
           <a:bodyPr wrap="square" rtlCol="0" anchor="ctr"/>
           <a:lstStyle/>
           <a:p>
-            <a:pPr indent="0" marL="0">
+            <a:pPr marL="0" indent="0">
               <a:buNone/>
             </a:pPr>
             <a:r>
@@ -8686,7 +8548,7 @@
           <a:bodyPr wrap="square" rtlCol="0" anchor="ctr"/>
           <a:lstStyle/>
           <a:p>
-            <a:pPr indent="0" marL="0">
+            <a:pPr marL="0" indent="0">
               <a:buNone/>
             </a:pPr>
             <a:r>
@@ -8725,7 +8587,7 @@
           <a:bodyPr wrap="square" rtlCol="0" anchor="ctr"/>
           <a:lstStyle/>
           <a:p>
-            <a:pPr indent="0" marL="0">
+            <a:pPr marL="0" indent="0">
               <a:buNone/>
             </a:pPr>
             <a:r>
@@ -8764,7 +8626,7 @@
           <a:bodyPr wrap="square" rtlCol="0" anchor="ctr"/>
           <a:lstStyle/>
           <a:p>
-            <a:pPr indent="0" marL="0">
+            <a:pPr marL="0" indent="0">
               <a:buNone/>
             </a:pPr>
             <a:r>
@@ -8825,7 +8687,7 @@
           <a:bodyPr wrap="square" rtlCol="0" anchor="ctr"/>
           <a:lstStyle/>
           <a:p>
-            <a:pPr indent="0" marL="0">
+            <a:pPr marL="0" indent="0">
               <a:buNone/>
             </a:pPr>
             <a:r>
@@ -8864,7 +8726,7 @@
           <a:bodyPr wrap="square" rtlCol="0" anchor="ctr"/>
           <a:lstStyle/>
           <a:p>
-            <a:pPr indent="0" marL="0">
+            <a:pPr marL="0" indent="0">
               <a:buNone/>
             </a:pPr>
             <a:r>
@@ -8903,7 +8765,7 @@
           <a:bodyPr wrap="square" rtlCol="0" anchor="ctr"/>
           <a:lstStyle/>
           <a:p>
-            <a:pPr indent="0" marL="0">
+            <a:pPr marL="0" indent="0">
               <a:buNone/>
             </a:pPr>
             <a:r>
@@ -8964,7 +8826,7 @@
           <a:bodyPr wrap="square" rtlCol="0" anchor="ctr"/>
           <a:lstStyle/>
           <a:p>
-            <a:pPr indent="0" marL="0">
+            <a:pPr marL="0" indent="0">
               <a:buNone/>
             </a:pPr>
             <a:r>
@@ -9003,7 +8865,7 @@
           <a:bodyPr wrap="square" rtlCol="0" anchor="ctr"/>
           <a:lstStyle/>
           <a:p>
-            <a:pPr indent="0" marL="0">
+            <a:pPr marL="0" indent="0">
               <a:buNone/>
             </a:pPr>
             <a:r>
@@ -9042,7 +8904,7 @@
           <a:bodyPr wrap="square" rtlCol="0" anchor="ctr"/>
           <a:lstStyle/>
           <a:p>
-            <a:pPr indent="0" marL="0">
+            <a:pPr marL="0" indent="0">
               <a:buNone/>
             </a:pPr>
             <a:r>
@@ -9103,7 +8965,7 @@
           <a:bodyPr wrap="square" rtlCol="0" anchor="ctr"/>
           <a:lstStyle/>
           <a:p>
-            <a:pPr indent="0" marL="0">
+            <a:pPr marL="0" indent="0">
               <a:buNone/>
             </a:pPr>
             <a:r>
@@ -9142,7 +9004,7 @@
           <a:bodyPr wrap="square" rtlCol="0" anchor="ctr"/>
           <a:lstStyle/>
           <a:p>
-            <a:pPr indent="0" marL="0">
+            <a:pPr marL="0" indent="0">
               <a:buNone/>
             </a:pPr>
             <a:r>
@@ -9181,7 +9043,7 @@
           <a:bodyPr wrap="square" rtlCol="0" anchor="ctr"/>
           <a:lstStyle/>
           <a:p>
-            <a:pPr indent="0" marL="0">
+            <a:pPr marL="0" indent="0">
               <a:buNone/>
             </a:pPr>
             <a:r>
@@ -9242,7 +9104,7 @@
           <a:bodyPr wrap="square" rtlCol="0" anchor="ctr"/>
           <a:lstStyle/>
           <a:p>
-            <a:pPr indent="0" marL="0">
+            <a:pPr marL="0" indent="0">
               <a:buNone/>
             </a:pPr>
             <a:r>
@@ -9281,7 +9143,7 @@
           <a:bodyPr wrap="square" rtlCol="0" anchor="ctr"/>
           <a:lstStyle/>
           <a:p>
-            <a:pPr indent="0" marL="0">
+            <a:pPr marL="0" indent="0">
               <a:buNone/>
             </a:pPr>
             <a:r>
@@ -9320,7 +9182,7 @@
           <a:bodyPr wrap="square" rtlCol="0" anchor="ctr"/>
           <a:lstStyle/>
           <a:p>
-            <a:pPr indent="0" marL="0">
+            <a:pPr marL="0" indent="0">
               <a:buNone/>
             </a:pPr>
             <a:r>
@@ -9359,7 +9221,7 @@
           <a:bodyPr wrap="square" rtlCol="0" anchor="ctr"/>
           <a:lstStyle/>
           <a:p>
-            <a:pPr indent="0" marL="0">
+            <a:pPr marL="0" indent="0">
               <a:buNone/>
             </a:pPr>
             <a:r>
@@ -9463,7 +9325,7 @@
           <a:bodyPr wrap="square" rtlCol="0" anchor="ctr"/>
           <a:lstStyle/>
           <a:p>
-            <a:pPr indent="0" marL="0">
+            <a:pPr marL="0" indent="0">
               <a:buNone/>
             </a:pPr>
             <a:r>
@@ -9522,7 +9384,7 @@
           <a:bodyPr wrap="square" rtlCol="0" anchor="ctr"/>
           <a:lstStyle/>
           <a:p>
-            <a:pPr indent="0" marL="0">
+            <a:pPr marL="0" indent="0">
               <a:buNone/>
             </a:pPr>
             <a:r>
@@ -9561,7 +9423,7 @@
           <a:bodyPr wrap="square" rtlCol="0" anchor="ctr"/>
           <a:lstStyle/>
           <a:p>
-            <a:pPr indent="0" marL="0">
+            <a:pPr marL="0" indent="0">
               <a:buNone/>
             </a:pPr>
             <a:r>
@@ -9600,7 +9462,7 @@
           <a:bodyPr wrap="square" rtlCol="0" anchor="ctr"/>
           <a:lstStyle/>
           <a:p>
-            <a:pPr indent="0" marL="0">
+            <a:pPr marL="0" indent="0">
               <a:buNone/>
             </a:pPr>
             <a:r>
@@ -9639,7 +9501,7 @@
           <a:bodyPr wrap="square" rtlCol="0" anchor="ctr"/>
           <a:lstStyle/>
           <a:p>
-            <a:pPr indent="0" marL="0">
+            <a:pPr marL="0" indent="0">
               <a:buNone/>
             </a:pPr>
             <a:r>
@@ -9678,7 +9540,7 @@
           <a:bodyPr wrap="square" rtlCol="0" anchor="ctr"/>
           <a:lstStyle/>
           <a:p>
-            <a:pPr indent="0" marL="0">
+            <a:pPr marL="0" indent="0">
               <a:buNone/>
             </a:pPr>
             <a:r>
@@ -9717,7 +9579,7 @@
           <a:bodyPr wrap="square" rtlCol="0" anchor="ctr"/>
           <a:lstStyle/>
           <a:p>
-            <a:pPr indent="0" marL="0">
+            <a:pPr marL="0" indent="0">
               <a:buNone/>
             </a:pPr>
             <a:r>
@@ -9756,7 +9618,7 @@
           <a:bodyPr wrap="square" rtlCol="0" anchor="ctr"/>
           <a:lstStyle/>
           <a:p>
-            <a:pPr indent="0" marL="0">
+            <a:pPr marL="0" indent="0">
               <a:buNone/>
             </a:pPr>
             <a:r>
@@ -10075,4 +9937,299 @@
     </a:ext>
   </a:extLst>
 </a:theme>
+</file>
+
+<file path=ppt/theme/theme2.xml><?xml version="1.0" encoding="utf-8"?>
+<a:theme xmlns:a="http://schemas.openxmlformats.org/drawingml/2006/main" name="Office Theme">
+  <a:themeElements>
+    <a:clrScheme name="Office">
+      <a:dk1>
+        <a:sysClr val="windowText" lastClr="000000"/>
+      </a:dk1>
+      <a:lt1>
+        <a:sysClr val="window" lastClr="FFFFFF"/>
+      </a:lt1>
+      <a:dk2>
+        <a:srgbClr val="44546A"/>
+      </a:dk2>
+      <a:lt2>
+        <a:srgbClr val="E7E6E6"/>
+      </a:lt2>
+      <a:accent1>
+        <a:srgbClr val="4472C4"/>
+      </a:accent1>
+      <a:accent2>
+        <a:srgbClr val="ED7D31"/>
+      </a:accent2>
+      <a:accent3>
+        <a:srgbClr val="A5A5A5"/>
+      </a:accent3>
+      <a:accent4>
+        <a:srgbClr val="FFC000"/>
+      </a:accent4>
+      <a:accent5>
+        <a:srgbClr val="5B9BD5"/>
+      </a:accent5>
+      <a:accent6>
+        <a:srgbClr val="70AD47"/>
+      </a:accent6>
+      <a:hlink>
+        <a:srgbClr val="0563C1"/>
+      </a:hlink>
+      <a:folHlink>
+        <a:srgbClr val="954F72"/>
+      </a:folHlink>
+    </a:clrScheme>
+    <a:fontScheme name="Office">
+      <a:majorFont>
+        <a:latin typeface="Calibri Light" panose="020F0302020204030204"/>
+        <a:ea typeface=""/>
+        <a:cs typeface=""/>
+        <a:font script="Jpan" typeface="游ゴシック Light"/>
+        <a:font script="Hang" typeface="맑은 고딕"/>
+        <a:font script="Hans" typeface="等线 Light"/>
+        <a:font script="Hant" typeface="新細明體"/>
+        <a:font script="Arab" typeface="Times New Roman"/>
+        <a:font script="Hebr" typeface="Times New Roman"/>
+        <a:font script="Thai" typeface="Angsana New"/>
+        <a:font script="Ethi" typeface="Nyala"/>
+        <a:font script="Beng" typeface="Vrinda"/>
+        <a:font script="Gujr" typeface="Shruti"/>
+        <a:font script="Khmr" typeface="MoolBoran"/>
+        <a:font script="Knda" typeface="Tunga"/>
+        <a:font script="Guru" typeface="Raavi"/>
+        <a:font script="Cans" typeface="Euphemia"/>
+        <a:font script="Cher" typeface="Plantagenet Cherokee"/>
+        <a:font script="Yiii" typeface="Microsoft Yi Baiti"/>
+        <a:font script="Tibt" typeface="Microsoft Himalaya"/>
+        <a:font script="Thaa" typeface="MV Boli"/>
+        <a:font script="Deva" typeface="Mangal"/>
+        <a:font script="Telu" typeface="Gautami"/>
+        <a:font script="Taml" typeface="Latha"/>
+        <a:font script="Syrc" typeface="Estrangelo Edessa"/>
+        <a:font script="Orya" typeface="Kalinga"/>
+        <a:font script="Mlym" typeface="Kartika"/>
+        <a:font script="Laoo" typeface="DokChampa"/>
+        <a:font script="Sinh" typeface="Iskoola Pota"/>
+        <a:font script="Mong" typeface="Mongolian Baiti"/>
+        <a:font script="Viet" typeface="Times New Roman"/>
+        <a:font script="Uigh" typeface="Microsoft Uighur"/>
+        <a:font script="Geor" typeface="Sylfaen"/>
+        <a:font script="Armn" typeface="Arial"/>
+        <a:font script="Bugi" typeface="Leelawadee UI"/>
+        <a:font script="Bopo" typeface="Microsoft JhengHei"/>
+        <a:font script="Java" typeface="Javanese Text"/>
+        <a:font script="Lisu" typeface="Segoe UI"/>
+        <a:font script="Mymr" typeface="Myanmar Text"/>
+        <a:font script="Nkoo" typeface="Ebrima"/>
+        <a:font script="Olck" typeface="Nirmala UI"/>
+        <a:font script="Osma" typeface="Ebrima"/>
+        <a:font script="Phag" typeface="Phagspa"/>
+        <a:font script="Syrn" typeface="Estrangelo Edessa"/>
+        <a:font script="Syrj" typeface="Estrangelo Edessa"/>
+        <a:font script="Syre" typeface="Estrangelo Edessa"/>
+        <a:font script="Sora" typeface="Nirmala UI"/>
+        <a:font script="Tale" typeface="Microsoft Tai Le"/>
+        <a:font script="Talu" typeface="Microsoft New Tai Lue"/>
+        <a:font script="Tfng" typeface="Ebrima"/>
+      </a:majorFont>
+      <a:minorFont>
+        <a:latin typeface="Calibri" panose="020F0502020204030204"/>
+        <a:ea typeface=""/>
+        <a:cs typeface=""/>
+        <a:font script="Jpan" typeface="游ゴシック"/>
+        <a:font script="Hang" typeface="맑은 고딕"/>
+        <a:font script="Hans" typeface="等线"/>
+        <a:font script="Hant" typeface="新細明體"/>
+        <a:font script="Arab" typeface="Arial"/>
+        <a:font script="Hebr" typeface="Arial"/>
+        <a:font script="Thai" typeface="Cordia New"/>
+        <a:font script="Ethi" typeface="Nyala"/>
+        <a:font script="Beng" typeface="Vrinda"/>
+        <a:font script="Gujr" typeface="Shruti"/>
+        <a:font script="Khmr" typeface="DaunPenh"/>
+        <a:font script="Knda" typeface="Tunga"/>
+        <a:font script="Guru" typeface="Raavi"/>
+        <a:font script="Cans" typeface="Euphemia"/>
+        <a:font script="Cher" typeface="Plantagenet Cherokee"/>
+        <a:font script="Yiii" typeface="Microsoft Yi Baiti"/>
+        <a:font script="Tibt" typeface="Microsoft Himalaya"/>
+        <a:font script="Thaa" typeface="MV Boli"/>
+        <a:font script="Deva" typeface="Mangal"/>
+        <a:font script="Telu" typeface="Gautami"/>
+        <a:font script="Taml" typeface="Latha"/>
+        <a:font script="Syrc" typeface="Estrangelo Edessa"/>
+        <a:font script="Orya" typeface="Kalinga"/>
+        <a:font script="Mlym" typeface="Kartika"/>
+        <a:font script="Laoo" typeface="DokChampa"/>
+        <a:font script="Sinh" typeface="Iskoola Pota"/>
+        <a:font script="Mong" typeface="Mongolian Baiti"/>
+        <a:font script="Viet" typeface="Arial"/>
+        <a:font script="Uigh" typeface="Microsoft Uighur"/>
+        <a:font script="Geor" typeface="Sylfaen"/>
+        <a:font script="Armn" typeface="Arial"/>
+        <a:font script="Bugi" typeface="Leelawadee UI"/>
+        <a:font script="Bopo" typeface="Microsoft JhengHei"/>
+        <a:font script="Java" typeface="Javanese Text"/>
+        <a:font script="Lisu" typeface="Segoe UI"/>
+        <a:font script="Mymr" typeface="Myanmar Text"/>
+        <a:font script="Nkoo" typeface="Ebrima"/>
+        <a:font script="Olck" typeface="Nirmala UI"/>
+        <a:font script="Osma" typeface="Ebrima"/>
+        <a:font script="Phag" typeface="Phagspa"/>
+        <a:font script="Syrn" typeface="Estrangelo Edessa"/>
+        <a:font script="Syrj" typeface="Estrangelo Edessa"/>
+        <a:font script="Syre" typeface="Estrangelo Edessa"/>
+        <a:font script="Sora" typeface="Nirmala UI"/>
+        <a:font script="Tale" typeface="Microsoft Tai Le"/>
+        <a:font script="Talu" typeface="Microsoft New Tai Lue"/>
+        <a:font script="Tfng" typeface="Ebrima"/>
+      </a:minorFont>
+    </a:fontScheme>
+    <a:fmtScheme name="Office">
+      <a:fillStyleLst>
+        <a:solidFill>
+          <a:schemeClr val="phClr"/>
+        </a:solidFill>
+        <a:gradFill rotWithShape="1">
+          <a:gsLst>
+            <a:gs pos="0">
+              <a:schemeClr val="phClr">
+                <a:lumMod val="110000"/>
+                <a:satMod val="105000"/>
+                <a:tint val="67000"/>
+              </a:schemeClr>
+            </a:gs>
+            <a:gs pos="50000">
+              <a:schemeClr val="phClr">
+                <a:lumMod val="105000"/>
+                <a:satMod val="103000"/>
+                <a:tint val="73000"/>
+              </a:schemeClr>
+            </a:gs>
+            <a:gs pos="100000">
+              <a:schemeClr val="phClr">
+                <a:lumMod val="105000"/>
+                <a:satMod val="109000"/>
+                <a:tint val="81000"/>
+              </a:schemeClr>
+            </a:gs>
+          </a:gsLst>
+          <a:lin ang="5400000" scaled="0"/>
+        </a:gradFill>
+        <a:gradFill rotWithShape="1">
+          <a:gsLst>
+            <a:gs pos="0">
+              <a:schemeClr val="phClr">
+                <a:satMod val="103000"/>
+                <a:lumMod val="102000"/>
+                <a:tint val="94000"/>
+              </a:schemeClr>
+            </a:gs>
+            <a:gs pos="50000">
+              <a:schemeClr val="phClr">
+                <a:satMod val="110000"/>
+                <a:lumMod val="100000"/>
+                <a:shade val="100000"/>
+              </a:schemeClr>
+            </a:gs>
+            <a:gs pos="100000">
+              <a:schemeClr val="phClr">
+                <a:lumMod val="99000"/>
+                <a:satMod val="120000"/>
+                <a:shade val="78000"/>
+              </a:schemeClr>
+            </a:gs>
+          </a:gsLst>
+          <a:lin ang="5400000" scaled="0"/>
+        </a:gradFill>
+      </a:fillStyleLst>
+      <a:lnStyleLst>
+        <a:ln w="6350" cap="flat" cmpd="sng" algn="ctr">
+          <a:solidFill>
+            <a:schemeClr val="phClr"/>
+          </a:solidFill>
+          <a:prstDash val="solid"/>
+          <a:miter lim="800000"/>
+        </a:ln>
+        <a:ln w="12700" cap="flat" cmpd="sng" algn="ctr">
+          <a:solidFill>
+            <a:schemeClr val="phClr"/>
+          </a:solidFill>
+          <a:prstDash val="solid"/>
+          <a:miter lim="800000"/>
+        </a:ln>
+        <a:ln w="19050" cap="flat" cmpd="sng" algn="ctr">
+          <a:solidFill>
+            <a:schemeClr val="phClr"/>
+          </a:solidFill>
+          <a:prstDash val="solid"/>
+          <a:miter lim="800000"/>
+        </a:ln>
+      </a:lnStyleLst>
+      <a:effectStyleLst>
+        <a:effectStyle>
+          <a:effectLst/>
+        </a:effectStyle>
+        <a:effectStyle>
+          <a:effectLst/>
+        </a:effectStyle>
+        <a:effectStyle>
+          <a:effectLst>
+            <a:outerShdw blurRad="57150" dist="19050" dir="5400000" algn="ctr" rotWithShape="0">
+              <a:srgbClr val="000000">
+                <a:alpha val="63000"/>
+              </a:srgbClr>
+            </a:outerShdw>
+          </a:effectLst>
+        </a:effectStyle>
+      </a:effectStyleLst>
+      <a:bgFillStyleLst>
+        <a:solidFill>
+          <a:schemeClr val="phClr"/>
+        </a:solidFill>
+        <a:solidFill>
+          <a:schemeClr val="phClr">
+            <a:tint val="95000"/>
+            <a:satMod val="170000"/>
+          </a:schemeClr>
+        </a:solidFill>
+        <a:gradFill rotWithShape="1">
+          <a:gsLst>
+            <a:gs pos="0">
+              <a:schemeClr val="phClr">
+                <a:tint val="93000"/>
+                <a:satMod val="150000"/>
+                <a:shade val="98000"/>
+                <a:lumMod val="102000"/>
+              </a:schemeClr>
+            </a:gs>
+            <a:gs pos="50000">
+              <a:schemeClr val="phClr">
+                <a:tint val="98000"/>
+                <a:satMod val="130000"/>
+                <a:shade val="90000"/>
+                <a:lumMod val="103000"/>
+              </a:schemeClr>
+            </a:gs>
+            <a:gs pos="100000">
+              <a:schemeClr val="phClr">
+                <a:shade val="63000"/>
+                <a:satMod val="120000"/>
+              </a:schemeClr>
+            </a:gs>
+          </a:gsLst>
+          <a:lin ang="5400000" scaled="0"/>
+        </a:gradFill>
+      </a:bgFillStyleLst>
+    </a:fmtScheme>
+  </a:themeElements>
+  <a:objectDefaults/>
+  <a:extraClrSchemeLst/>
+  <a:extLst>
+    <a:ext uri="{05A4C25C-085E-4340-85A3-A5531E510DB2}">
+      <thm15:themeFamily xmlns:thm15="http://schemas.microsoft.com/office/thememl/2012/main" name="Office Theme" id="{62F939B6-93AF-4DB8-9C6B-D6C7DFDC589F}" vid="{4A3C46E8-61CC-4603-A589-7422A47A8E4A}"/>
+    </a:ext>
+  </a:extLst>
+</a:theme>
 </file>
</xml_diff>